<commit_message>
fix: enforce chart category admission rules
</commit_message>
<xml_diff>
--- a/output/phase1_citation_fix/002444/presentation.pptx
+++ b/output/phase1_citation_fix/002444/presentation.pptx
@@ -130,171 +130,6 @@
     </a:lvl9pPr>
   </p:defaultTextStyle>
 </p:presentation>
-</file>
-
-<file path=ppt/charts/chart1.xml><?xml version="1.0" encoding="utf-8"?>
-<c:chartSpace xmlns:c="http://schemas.openxmlformats.org/drawingml/2006/chart" xmlns:a="http://schemas.openxmlformats.org/drawingml/2006/main" xmlns:r="http://schemas.openxmlformats.org/officeDocument/2006/relationships">
-  <c:date1904 val="0"/>
-  <c:chart>
-    <c:autoTitleDeleted val="1"/>
-    <c:plotArea>
-      <c:barChart>
-        <c:barDir val="col"/>
-        <c:grouping val="clustered"/>
-        <c:ser>
-          <c:idx val="0"/>
-          <c:order val="0"/>
-          <c:tx>
-            <c:strRef>
-              <c:f>Sheet1!$B$1</c:f>
-              <c:strCache>
-                <c:ptCount val="1"/>
-                <c:pt idx="0">
-                  <c:v>泉峰控股</c:v>
-                </c:pt>
-              </c:strCache>
-            </c:strRef>
-          </c:tx>
-          <c:spPr>
-            <a:solidFill>
-              <a:srgbClr val="2F75B5"/>
-            </a:solidFill>
-            <a:ln>
-              <a:solidFill>
-                <a:srgbClr val="2F75B5"/>
-              </a:solidFill>
-            </a:ln>
-          </c:spPr>
-          <c:cat>
-            <c:strRef>
-              <c:f>Sheet1!$A$2:$A$3</c:f>
-              <c:strCache>
-                <c:ptCount val="2"/>
-                <c:pt idx="0">
-                  <c:v>2025E PE (X)</c:v>
-                </c:pt>
-                <c:pt idx="1">
-                  <c:v>2026E PE (X)</c:v>
-                </c:pt>
-              </c:strCache>
-            </c:strRef>
-          </c:cat>
-          <c:val>
-            <c:numRef>
-              <c:f>Sheet1!$B$2:$B$3</c:f>
-              <c:numCache>
-                <c:formatCode>General</c:formatCode>
-                <c:ptCount val="2"/>
-                <c:pt idx="0">
-                  <c:v>6.6</c:v>
-                </c:pt>
-                <c:pt idx="1">
-                  <c:v>5.3</c:v>
-                </c:pt>
-              </c:numCache>
-            </c:numRef>
-          </c:val>
-        </c:ser>
-        <c:gapWidth val="65"/>
-        <c:axId val="79456312"/>
-        <c:axId val="33489208"/>
-      </c:barChart>
-      <c:catAx>
-        <c:axId val="79456312"/>
-        <c:scaling>
-          <c:orientation val="minMax"/>
-        </c:scaling>
-        <c:delete val="0"/>
-        <c:axPos val="b"/>
-        <c:majorTickMark val="out"/>
-        <c:minorTickMark val="none"/>
-        <c:tickLblPos val="nextTo"/>
-        <c:spPr>
-          <a:ln>
-            <a:solidFill>
-              <a:srgbClr val="94A3B8"/>
-            </a:solidFill>
-          </a:ln>
-        </c:spPr>
-        <c:txPr>
-          <a:bodyPr/>
-          <a:lstStyle/>
-          <a:p>
-            <a:pPr>
-              <a:defRPr sz="1000">
-                <a:solidFill>
-                  <a:srgbClr val="64748B"/>
-                </a:solidFill>
-                <a:latin typeface="Microsoft YaHei"/>
-              </a:defRPr>
-            </a:pPr>
-          </a:p>
-        </c:txPr>
-        <c:crossAx val="33489208"/>
-        <c:crosses val="autoZero"/>
-        <c:auto val="1"/>
-        <c:lblAlgn val="ctr"/>
-        <c:lblOffset val="100"/>
-        <c:noMultiLvlLbl val="0"/>
-      </c:catAx>
-      <c:valAx>
-        <c:axId val="33489208"/>
-        <c:scaling/>
-        <c:delete val="0"/>
-        <c:axPos val="l"/>
-        <c:majorGridlines>
-          <c:spPr>
-            <a:ln w="9525">
-              <a:solidFill>
-                <a:srgbClr val="E2E8F0"/>
-              </a:solidFill>
-            </a:ln>
-          </c:spPr>
-        </c:majorGridlines>
-        <c:majorTickMark val="out"/>
-        <c:minorTickMark val="none"/>
-        <c:tickLblPos val="nextTo"/>
-        <c:spPr>
-          <a:ln>
-            <a:solidFill>
-              <a:srgbClr val="94A3B8"/>
-            </a:solidFill>
-          </a:ln>
-        </c:spPr>
-        <c:txPr>
-          <a:bodyPr/>
-          <a:lstStyle/>
-          <a:p>
-            <a:pPr>
-              <a:defRPr sz="1000">
-                <a:solidFill>
-                  <a:srgbClr val="64748B"/>
-                </a:solidFill>
-                <a:latin typeface="Microsoft YaHei"/>
-              </a:defRPr>
-            </a:pPr>
-          </a:p>
-        </c:txPr>
-        <c:crossAx val="79456312"/>
-        <c:crosses val="autoZero"/>
-      </c:valAx>
-    </c:plotArea>
-    <c:dispBlanksAs val="gap"/>
-  </c:chart>
-  <c:txPr>
-    <a:bodyPr/>
-    <a:lstStyle/>
-    <a:p>
-      <a:pPr>
-        <a:defRPr sz="1800"/>
-      </a:pPr>
-      <a:endParaRPr lang="en-US"/>
-    </a:p>
-  </c:txPr>
-  <c:externalData r:id="rId1">
-    <c:autoUpdate val="0"/>
-  </c:externalData>
-</c:chartSpace>
 </file>
 
 <file path=ppt/notesMasters/notesMaster1.xml><?xml version="1.0" encoding="utf-8"?>
@@ -12018,16 +11853,756 @@
           </a:p>
         </p:txBody>
       </p:sp>
+      <p:graphicFrame>
+        <p:nvGraphicFramePr>
+          <p:cNvPr id="3" name="compiled_table"/>
+          <p:cNvGraphicFramePr>
+            <a:graphicFrameLocks noGrp="1"/>
+          </p:cNvGraphicFramePr>
+          <p:nvPr/>
+        </p:nvGraphicFramePr>
+        <p:xfrm>
+          <a:off x="731520" y="1508760"/>
+          <a:ext cx="5242529" cy="1041400"/>
+        </p:xfrm>
+        <a:graphic>
+          <a:graphicData uri="http://schemas.openxmlformats.org/drawingml/2006/table">
+            <a:tbl>
+              <a:tblPr firstRow="1" bandRow="1">
+                <a:tableStyleId>{5C22544A-7EE6-4342-B048-85BDC9FD1C3A}</a:tableStyleId>
+              </a:tblPr>
+              <a:tblGrid>
+                <a:gridCol w="1314468"/>
+                <a:gridCol w="930868"/>
+                <a:gridCol w="930868"/>
+                <a:gridCol w="1135455"/>
+                <a:gridCol w="930870"/>
+              </a:tblGrid>
+              <a:tr h="381000">
+                <a:tc>
+                  <a:txBody>
+                    <a:bodyPr wrap="square"/>
+                    <a:lstStyle/>
+                    <a:p>
+                      <a:pPr algn="ctr"/>
+                      <a:r>
+                        <a:rPr sz="1000" b="1">
+                          <a:solidFill>
+                            <a:srgbClr val="FFFFFF"/>
+                          </a:solidFill>
+                          <a:latin typeface="Microsoft YaHei"/>
+                        </a:rPr>
+                        <a:t>估值指标</a:t>
+                      </a:r>
+                    </a:p>
+                  </a:txBody>
+                  <a:tcPr marL="63500" marR="63500" marT="38100" marB="38100" anchor="ctr">
+                    <a:lnL w="7620">
+                      <a:solidFill>
+                        <a:srgbClr val="D9E2EC"/>
+                      </a:solidFill>
+                      <a:prstDash val="solid"/>
+                    </a:lnL>
+                    <a:lnR w="7620">
+                      <a:solidFill>
+                        <a:srgbClr val="D9E2EC"/>
+                      </a:solidFill>
+                      <a:prstDash val="solid"/>
+                    </a:lnR>
+                    <a:lnT w="7620">
+                      <a:solidFill>
+                        <a:srgbClr val="D9E2EC"/>
+                      </a:solidFill>
+                      <a:prstDash val="solid"/>
+                    </a:lnT>
+                    <a:lnB w="7620">
+                      <a:solidFill>
+                        <a:srgbClr val="D9E2EC"/>
+                      </a:solidFill>
+                      <a:prstDash val="solid"/>
+                    </a:lnB>
+                    <a:solidFill>
+                      <a:srgbClr val="102A43"/>
+                    </a:solidFill>
+                  </a:tcPr>
+                </a:tc>
+                <a:tc>
+                  <a:txBody>
+                    <a:bodyPr wrap="square"/>
+                    <a:lstStyle/>
+                    <a:p>
+                      <a:pPr algn="ctr"/>
+                      <a:r>
+                        <a:rPr sz="1000" b="1">
+                          <a:solidFill>
+                            <a:srgbClr val="FFFFFF"/>
+                          </a:solidFill>
+                          <a:latin typeface="Microsoft YaHei"/>
+                        </a:rPr>
+                        <a:t>泉峰控股</a:t>
+                      </a:r>
+                    </a:p>
+                  </a:txBody>
+                  <a:tcPr marL="63500" marR="63500" marT="38100" marB="38100" anchor="ctr">
+                    <a:lnL w="7620">
+                      <a:solidFill>
+                        <a:srgbClr val="D9E2EC"/>
+                      </a:solidFill>
+                      <a:prstDash val="solid"/>
+                    </a:lnL>
+                    <a:lnR w="7620">
+                      <a:solidFill>
+                        <a:srgbClr val="D9E2EC"/>
+                      </a:solidFill>
+                      <a:prstDash val="solid"/>
+                    </a:lnR>
+                    <a:lnT w="7620">
+                      <a:solidFill>
+                        <a:srgbClr val="D9E2EC"/>
+                      </a:solidFill>
+                      <a:prstDash val="solid"/>
+                    </a:lnT>
+                    <a:lnB w="7620">
+                      <a:solidFill>
+                        <a:srgbClr val="D9E2EC"/>
+                      </a:solidFill>
+                      <a:prstDash val="solid"/>
+                    </a:lnB>
+                    <a:solidFill>
+                      <a:srgbClr val="102A43"/>
+                    </a:solidFill>
+                  </a:tcPr>
+                </a:tc>
+                <a:tc>
+                  <a:txBody>
+                    <a:bodyPr wrap="square"/>
+                    <a:lstStyle/>
+                    <a:p>
+                      <a:pPr algn="ctr"/>
+                      <a:r>
+                        <a:rPr sz="1000" b="1">
+                          <a:solidFill>
+                            <a:srgbClr val="FFFFFF"/>
+                          </a:solidFill>
+                          <a:latin typeface="Microsoft YaHei"/>
+                        </a:rPr>
+                        <a:t>创科实业</a:t>
+                      </a:r>
+                    </a:p>
+                  </a:txBody>
+                  <a:tcPr marL="63500" marR="63500" marT="38100" marB="38100" anchor="ctr">
+                    <a:lnL w="7620">
+                      <a:solidFill>
+                        <a:srgbClr val="D9E2EC"/>
+                      </a:solidFill>
+                      <a:prstDash val="solid"/>
+                    </a:lnL>
+                    <a:lnR w="7620">
+                      <a:solidFill>
+                        <a:srgbClr val="D9E2EC"/>
+                      </a:solidFill>
+                      <a:prstDash val="solid"/>
+                    </a:lnR>
+                    <a:lnT w="7620">
+                      <a:solidFill>
+                        <a:srgbClr val="D9E2EC"/>
+                      </a:solidFill>
+                      <a:prstDash val="solid"/>
+                    </a:lnT>
+                    <a:lnB w="7620">
+                      <a:solidFill>
+                        <a:srgbClr val="D9E2EC"/>
+                      </a:solidFill>
+                      <a:prstDash val="solid"/>
+                    </a:lnB>
+                    <a:solidFill>
+                      <a:srgbClr val="102A43"/>
+                    </a:solidFill>
+                  </a:tcPr>
+                </a:tc>
+                <a:tc>
+                  <a:txBody>
+                    <a:bodyPr wrap="square"/>
+                    <a:lstStyle/>
+                    <a:p>
+                      <a:pPr algn="ctr"/>
+                      <a:r>
+                        <a:rPr sz="1000" b="1">
+                          <a:solidFill>
+                            <a:srgbClr val="FFFFFF"/>
+                          </a:solidFill>
+                          <a:latin typeface="Microsoft YaHei"/>
+                        </a:rPr>
+                        <a:t>可比公司均值</a:t>
+                      </a:r>
+                    </a:p>
+                  </a:txBody>
+                  <a:tcPr marL="63500" marR="63500" marT="38100" marB="38100" anchor="ctr">
+                    <a:lnL w="7620">
+                      <a:solidFill>
+                        <a:srgbClr val="D9E2EC"/>
+                      </a:solidFill>
+                      <a:prstDash val="solid"/>
+                    </a:lnL>
+                    <a:lnR w="7620">
+                      <a:solidFill>
+                        <a:srgbClr val="D9E2EC"/>
+                      </a:solidFill>
+                      <a:prstDash val="solid"/>
+                    </a:lnR>
+                    <a:lnT w="7620">
+                      <a:solidFill>
+                        <a:srgbClr val="D9E2EC"/>
+                      </a:solidFill>
+                      <a:prstDash val="solid"/>
+                    </a:lnT>
+                    <a:lnB w="7620">
+                      <a:solidFill>
+                        <a:srgbClr val="D9E2EC"/>
+                      </a:solidFill>
+                      <a:prstDash val="solid"/>
+                    </a:lnB>
+                    <a:solidFill>
+                      <a:srgbClr val="102A43"/>
+                    </a:solidFill>
+                  </a:tcPr>
+                </a:tc>
+                <a:tc>
+                  <a:txBody>
+                    <a:bodyPr wrap="square"/>
+                    <a:lstStyle/>
+                    <a:p>
+                      <a:pPr algn="ctr"/>
+                      <a:r>
+                        <a:rPr sz="1000" b="1">
+                          <a:solidFill>
+                            <a:srgbClr val="FFFFFF"/>
+                          </a:solidFill>
+                          <a:latin typeface="Microsoft YaHei"/>
+                        </a:rPr>
+                        <a:t>巨星科技</a:t>
+                      </a:r>
+                    </a:p>
+                  </a:txBody>
+                  <a:tcPr marL="63500" marR="63500" marT="38100" marB="38100" anchor="ctr">
+                    <a:lnL w="7620">
+                      <a:solidFill>
+                        <a:srgbClr val="D9E2EC"/>
+                      </a:solidFill>
+                      <a:prstDash val="solid"/>
+                    </a:lnL>
+                    <a:lnR w="7620">
+                      <a:solidFill>
+                        <a:srgbClr val="D9E2EC"/>
+                      </a:solidFill>
+                      <a:prstDash val="solid"/>
+                    </a:lnR>
+                    <a:lnT w="7620">
+                      <a:solidFill>
+                        <a:srgbClr val="D9E2EC"/>
+                      </a:solidFill>
+                      <a:prstDash val="solid"/>
+                    </a:lnT>
+                    <a:lnB w="7620">
+                      <a:solidFill>
+                        <a:srgbClr val="D9E2EC"/>
+                      </a:solidFill>
+                      <a:prstDash val="solid"/>
+                    </a:lnB>
+                    <a:solidFill>
+                      <a:srgbClr val="102A43"/>
+                    </a:solidFill>
+                  </a:tcPr>
+                </a:tc>
+              </a:tr>
+              <a:tr h="330200">
+                <a:tc>
+                  <a:txBody>
+                    <a:bodyPr wrap="square"/>
+                    <a:lstStyle/>
+                    <a:p>
+                      <a:pPr algn="ctr"/>
+                      <a:r>
+                        <a:rPr sz="1000" b="1">
+                          <a:solidFill>
+                            <a:srgbClr val="64748B"/>
+                          </a:solidFill>
+                          <a:latin typeface="Microsoft YaHei"/>
+                        </a:rPr>
+                        <a:t>2025E PE (X)</a:t>
+                      </a:r>
+                    </a:p>
+                  </a:txBody>
+                  <a:tcPr marL="63500" marR="63500" marT="38100" marB="38100" anchor="ctr">
+                    <a:lnL w="7620">
+                      <a:solidFill>
+                        <a:srgbClr val="D9E2EC"/>
+                      </a:solidFill>
+                      <a:prstDash val="solid"/>
+                    </a:lnL>
+                    <a:lnR w="7620">
+                      <a:solidFill>
+                        <a:srgbClr val="D9E2EC"/>
+                      </a:solidFill>
+                      <a:prstDash val="solid"/>
+                    </a:lnR>
+                    <a:lnT w="7620">
+                      <a:solidFill>
+                        <a:srgbClr val="D9E2EC"/>
+                      </a:solidFill>
+                      <a:prstDash val="solid"/>
+                    </a:lnT>
+                    <a:lnB w="7620">
+                      <a:solidFill>
+                        <a:srgbClr val="D9E2EC"/>
+                      </a:solidFill>
+                      <a:prstDash val="solid"/>
+                    </a:lnB>
+                    <a:solidFill>
+                      <a:srgbClr val="FFFFFF"/>
+                    </a:solidFill>
+                  </a:tcPr>
+                </a:tc>
+                <a:tc>
+                  <a:txBody>
+                    <a:bodyPr wrap="square"/>
+                    <a:lstStyle/>
+                    <a:p>
+                      <a:pPr algn="ctr"/>
+                      <a:r>
+                        <a:rPr sz="1000" b="0">
+                          <a:solidFill>
+                            <a:srgbClr val="64748B"/>
+                          </a:solidFill>
+                          <a:latin typeface="Microsoft YaHei"/>
+                        </a:rPr>
+                        <a:t>6.6</a:t>
+                      </a:r>
+                    </a:p>
+                  </a:txBody>
+                  <a:tcPr marL="63500" marR="63500" marT="38100" marB="38100" anchor="ctr">
+                    <a:lnL w="7620">
+                      <a:solidFill>
+                        <a:srgbClr val="D9E2EC"/>
+                      </a:solidFill>
+                      <a:prstDash val="solid"/>
+                    </a:lnL>
+                    <a:lnR w="7620">
+                      <a:solidFill>
+                        <a:srgbClr val="D9E2EC"/>
+                      </a:solidFill>
+                      <a:prstDash val="solid"/>
+                    </a:lnR>
+                    <a:lnT w="7620">
+                      <a:solidFill>
+                        <a:srgbClr val="D9E2EC"/>
+                      </a:solidFill>
+                      <a:prstDash val="solid"/>
+                    </a:lnT>
+                    <a:lnB w="7620">
+                      <a:solidFill>
+                        <a:srgbClr val="D9E2EC"/>
+                      </a:solidFill>
+                      <a:prstDash val="solid"/>
+                    </a:lnB>
+                    <a:solidFill>
+                      <a:srgbClr val="FFFFFF"/>
+                    </a:solidFill>
+                  </a:tcPr>
+                </a:tc>
+                <a:tc>
+                  <a:txBody>
+                    <a:bodyPr wrap="square"/>
+                    <a:lstStyle/>
+                    <a:p>
+                      <a:pPr algn="ctr"/>
+                      <a:r>
+                        <a:rPr sz="1000" b="0">
+                          <a:solidFill>
+                            <a:srgbClr val="64748B"/>
+                          </a:solidFill>
+                          <a:latin typeface="Microsoft YaHei"/>
+                        </a:rPr>
+                        <a:t>15.2</a:t>
+                      </a:r>
+                    </a:p>
+                  </a:txBody>
+                  <a:tcPr marL="63500" marR="63500" marT="38100" marB="38100" anchor="ctr">
+                    <a:lnL w="7620">
+                      <a:solidFill>
+                        <a:srgbClr val="D9E2EC"/>
+                      </a:solidFill>
+                      <a:prstDash val="solid"/>
+                    </a:lnL>
+                    <a:lnR w="7620">
+                      <a:solidFill>
+                        <a:srgbClr val="D9E2EC"/>
+                      </a:solidFill>
+                      <a:prstDash val="solid"/>
+                    </a:lnR>
+                    <a:lnT w="7620">
+                      <a:solidFill>
+                        <a:srgbClr val="D9E2EC"/>
+                      </a:solidFill>
+                      <a:prstDash val="solid"/>
+                    </a:lnT>
+                    <a:lnB w="7620">
+                      <a:solidFill>
+                        <a:srgbClr val="D9E2EC"/>
+                      </a:solidFill>
+                      <a:prstDash val="solid"/>
+                    </a:lnB>
+                    <a:solidFill>
+                      <a:srgbClr val="FFFFFF"/>
+                    </a:solidFill>
+                  </a:tcPr>
+                </a:tc>
+                <a:tc>
+                  <a:txBody>
+                    <a:bodyPr wrap="square"/>
+                    <a:lstStyle/>
+                    <a:p>
+                      <a:pPr algn="ctr"/>
+                      <a:r>
+                        <a:rPr sz="1000" b="0">
+                          <a:solidFill>
+                            <a:srgbClr val="64748B"/>
+                          </a:solidFill>
+                          <a:latin typeface="Microsoft YaHei"/>
+                        </a:rPr>
+                        <a:t>10.9</a:t>
+                      </a:r>
+                    </a:p>
+                  </a:txBody>
+                  <a:tcPr marL="63500" marR="63500" marT="38100" marB="38100" anchor="ctr">
+                    <a:lnL w="7620">
+                      <a:solidFill>
+                        <a:srgbClr val="D9E2EC"/>
+                      </a:solidFill>
+                      <a:prstDash val="solid"/>
+                    </a:lnL>
+                    <a:lnR w="7620">
+                      <a:solidFill>
+                        <a:srgbClr val="D9E2EC"/>
+                      </a:solidFill>
+                      <a:prstDash val="solid"/>
+                    </a:lnR>
+                    <a:lnT w="7620">
+                      <a:solidFill>
+                        <a:srgbClr val="D9E2EC"/>
+                      </a:solidFill>
+                      <a:prstDash val="solid"/>
+                    </a:lnT>
+                    <a:lnB w="7620">
+                      <a:solidFill>
+                        <a:srgbClr val="D9E2EC"/>
+                      </a:solidFill>
+                      <a:prstDash val="solid"/>
+                    </a:lnB>
+                    <a:solidFill>
+                      <a:srgbClr val="FFFFFF"/>
+                    </a:solidFill>
+                  </a:tcPr>
+                </a:tc>
+                <a:tc>
+                  <a:txBody>
+                    <a:bodyPr wrap="square"/>
+                    <a:lstStyle/>
+                    <a:p>
+                      <a:pPr algn="ctr"/>
+                      <a:r>
+                        <a:rPr sz="1000" b="0">
+                          <a:solidFill>
+                            <a:srgbClr val="64748B"/>
+                          </a:solidFill>
+                          <a:latin typeface="Microsoft YaHei"/>
+                        </a:rPr>
+                        <a:t>12</a:t>
+                      </a:r>
+                    </a:p>
+                  </a:txBody>
+                  <a:tcPr marL="63500" marR="63500" marT="38100" marB="38100" anchor="ctr">
+                    <a:lnL w="7620">
+                      <a:solidFill>
+                        <a:srgbClr val="D9E2EC"/>
+                      </a:solidFill>
+                      <a:prstDash val="solid"/>
+                    </a:lnL>
+                    <a:lnR w="7620">
+                      <a:solidFill>
+                        <a:srgbClr val="D9E2EC"/>
+                      </a:solidFill>
+                      <a:prstDash val="solid"/>
+                    </a:lnR>
+                    <a:lnT w="7620">
+                      <a:solidFill>
+                        <a:srgbClr val="D9E2EC"/>
+                      </a:solidFill>
+                      <a:prstDash val="solid"/>
+                    </a:lnT>
+                    <a:lnB w="7620">
+                      <a:solidFill>
+                        <a:srgbClr val="D9E2EC"/>
+                      </a:solidFill>
+                      <a:prstDash val="solid"/>
+                    </a:lnB>
+                    <a:solidFill>
+                      <a:srgbClr val="FFFFFF"/>
+                    </a:solidFill>
+                  </a:tcPr>
+                </a:tc>
+              </a:tr>
+              <a:tr h="330200">
+                <a:tc>
+                  <a:txBody>
+                    <a:bodyPr wrap="square"/>
+                    <a:lstStyle/>
+                    <a:p>
+                      <a:pPr algn="ctr"/>
+                      <a:r>
+                        <a:rPr sz="1000" b="1">
+                          <a:solidFill>
+                            <a:srgbClr val="64748B"/>
+                          </a:solidFill>
+                          <a:latin typeface="Microsoft YaHei"/>
+                        </a:rPr>
+                        <a:t>2026E PE (X)</a:t>
+                      </a:r>
+                    </a:p>
+                  </a:txBody>
+                  <a:tcPr marL="63500" marR="63500" marT="38100" marB="38100" anchor="ctr">
+                    <a:lnL w="7620">
+                      <a:solidFill>
+                        <a:srgbClr val="D9E2EC"/>
+                      </a:solidFill>
+                      <a:prstDash val="solid"/>
+                    </a:lnL>
+                    <a:lnR w="7620">
+                      <a:solidFill>
+                        <a:srgbClr val="D9E2EC"/>
+                      </a:solidFill>
+                      <a:prstDash val="solid"/>
+                    </a:lnR>
+                    <a:lnT w="7620">
+                      <a:solidFill>
+                        <a:srgbClr val="D9E2EC"/>
+                      </a:solidFill>
+                      <a:prstDash val="solid"/>
+                    </a:lnT>
+                    <a:lnB w="7620">
+                      <a:solidFill>
+                        <a:srgbClr val="D9E2EC"/>
+                      </a:solidFill>
+                      <a:prstDash val="solid"/>
+                    </a:lnB>
+                    <a:solidFill>
+                      <a:srgbClr val="F5F7FA"/>
+                    </a:solidFill>
+                  </a:tcPr>
+                </a:tc>
+                <a:tc>
+                  <a:txBody>
+                    <a:bodyPr wrap="square"/>
+                    <a:lstStyle/>
+                    <a:p>
+                      <a:pPr algn="ctr"/>
+                      <a:r>
+                        <a:rPr sz="1000" b="0">
+                          <a:solidFill>
+                            <a:srgbClr val="64748B"/>
+                          </a:solidFill>
+                          <a:latin typeface="Microsoft YaHei"/>
+                        </a:rPr>
+                        <a:t>5.3</a:t>
+                      </a:r>
+                    </a:p>
+                  </a:txBody>
+                  <a:tcPr marL="63500" marR="63500" marT="38100" marB="38100" anchor="ctr">
+                    <a:lnL w="7620">
+                      <a:solidFill>
+                        <a:srgbClr val="D9E2EC"/>
+                      </a:solidFill>
+                      <a:prstDash val="solid"/>
+                    </a:lnL>
+                    <a:lnR w="7620">
+                      <a:solidFill>
+                        <a:srgbClr val="D9E2EC"/>
+                      </a:solidFill>
+                      <a:prstDash val="solid"/>
+                    </a:lnR>
+                    <a:lnT w="7620">
+                      <a:solidFill>
+                        <a:srgbClr val="D9E2EC"/>
+                      </a:solidFill>
+                      <a:prstDash val="solid"/>
+                    </a:lnT>
+                    <a:lnB w="7620">
+                      <a:solidFill>
+                        <a:srgbClr val="D9E2EC"/>
+                      </a:solidFill>
+                      <a:prstDash val="solid"/>
+                    </a:lnB>
+                    <a:solidFill>
+                      <a:srgbClr val="F5F7FA"/>
+                    </a:solidFill>
+                  </a:tcPr>
+                </a:tc>
+                <a:tc>
+                  <a:txBody>
+                    <a:bodyPr wrap="square"/>
+                    <a:lstStyle/>
+                    <a:p>
+                      <a:pPr algn="ctr"/>
+                      <a:r>
+                        <a:rPr sz="1000" b="0">
+                          <a:solidFill>
+                            <a:srgbClr val="64748B"/>
+                          </a:solidFill>
+                          <a:latin typeface="Microsoft YaHei"/>
+                        </a:rPr>
+                        <a:t>13.2</a:t>
+                      </a:r>
+                    </a:p>
+                  </a:txBody>
+                  <a:tcPr marL="63500" marR="63500" marT="38100" marB="38100" anchor="ctr">
+                    <a:lnL w="7620">
+                      <a:solidFill>
+                        <a:srgbClr val="D9E2EC"/>
+                      </a:solidFill>
+                      <a:prstDash val="solid"/>
+                    </a:lnL>
+                    <a:lnR w="7620">
+                      <a:solidFill>
+                        <a:srgbClr val="D9E2EC"/>
+                      </a:solidFill>
+                      <a:prstDash val="solid"/>
+                    </a:lnR>
+                    <a:lnT w="7620">
+                      <a:solidFill>
+                        <a:srgbClr val="D9E2EC"/>
+                      </a:solidFill>
+                      <a:prstDash val="solid"/>
+                    </a:lnT>
+                    <a:lnB w="7620">
+                      <a:solidFill>
+                        <a:srgbClr val="D9E2EC"/>
+                      </a:solidFill>
+                      <a:prstDash val="solid"/>
+                    </a:lnB>
+                    <a:solidFill>
+                      <a:srgbClr val="F5F7FA"/>
+                    </a:solidFill>
+                  </a:tcPr>
+                </a:tc>
+                <a:tc>
+                  <a:txBody>
+                    <a:bodyPr wrap="square"/>
+                    <a:lstStyle/>
+                    <a:p>
+                      <a:pPr algn="ctr"/>
+                      <a:r>
+                        <a:rPr sz="1000" b="0">
+                          <a:solidFill>
+                            <a:srgbClr val="64748B"/>
+                          </a:solidFill>
+                          <a:latin typeface="Microsoft YaHei"/>
+                        </a:rPr>
+                        <a:t>9.2</a:t>
+                      </a:r>
+                    </a:p>
+                  </a:txBody>
+                  <a:tcPr marL="63500" marR="63500" marT="38100" marB="38100" anchor="ctr">
+                    <a:lnL w="7620">
+                      <a:solidFill>
+                        <a:srgbClr val="D9E2EC"/>
+                      </a:solidFill>
+                      <a:prstDash val="solid"/>
+                    </a:lnL>
+                    <a:lnR w="7620">
+                      <a:solidFill>
+                        <a:srgbClr val="D9E2EC"/>
+                      </a:solidFill>
+                      <a:prstDash val="solid"/>
+                    </a:lnR>
+                    <a:lnT w="7620">
+                      <a:solidFill>
+                        <a:srgbClr val="D9E2EC"/>
+                      </a:solidFill>
+                      <a:prstDash val="solid"/>
+                    </a:lnT>
+                    <a:lnB w="7620">
+                      <a:solidFill>
+                        <a:srgbClr val="D9E2EC"/>
+                      </a:solidFill>
+                      <a:prstDash val="solid"/>
+                    </a:lnB>
+                    <a:solidFill>
+                      <a:srgbClr val="F5F7FA"/>
+                    </a:solidFill>
+                  </a:tcPr>
+                </a:tc>
+                <a:tc>
+                  <a:txBody>
+                    <a:bodyPr wrap="square"/>
+                    <a:lstStyle/>
+                    <a:p>
+                      <a:pPr algn="ctr"/>
+                      <a:r>
+                        <a:rPr sz="1000" b="0">
+                          <a:solidFill>
+                            <a:srgbClr val="64748B"/>
+                          </a:solidFill>
+                          <a:latin typeface="Microsoft YaHei"/>
+                        </a:rPr>
+                        <a:t>9.7</a:t>
+                      </a:r>
+                    </a:p>
+                  </a:txBody>
+                  <a:tcPr marL="63500" marR="63500" marT="38100" marB="38100" anchor="ctr">
+                    <a:lnL w="7620">
+                      <a:solidFill>
+                        <a:srgbClr val="D9E2EC"/>
+                      </a:solidFill>
+                      <a:prstDash val="solid"/>
+                    </a:lnL>
+                    <a:lnR w="7620">
+                      <a:solidFill>
+                        <a:srgbClr val="D9E2EC"/>
+                      </a:solidFill>
+                      <a:prstDash val="solid"/>
+                    </a:lnR>
+                    <a:lnT w="7620">
+                      <a:solidFill>
+                        <a:srgbClr val="D9E2EC"/>
+                      </a:solidFill>
+                      <a:prstDash val="solid"/>
+                    </a:lnT>
+                    <a:lnB w="7620">
+                      <a:solidFill>
+                        <a:srgbClr val="D9E2EC"/>
+                      </a:solidFill>
+                      <a:prstDash val="solid"/>
+                    </a:lnB>
+                    <a:solidFill>
+                      <a:srgbClr val="F5F7FA"/>
+                    </a:solidFill>
+                  </a:tcPr>
+                </a:tc>
+              </a:tr>
+            </a:tbl>
+          </a:graphicData>
+        </a:graphic>
+      </p:graphicFrame>
       <p:sp>
         <p:nvSpPr>
-          <p:cNvPr id="3" name="TextBox 2"/>
+          <p:cNvPr id="4" name="TextBox 3"/>
           <p:cNvSpPr txBox="1"/>
           <p:nvPr/>
         </p:nvSpPr>
         <p:spPr>
           <a:xfrm>
-            <a:off x="731520" y="1371600"/>
-            <a:ext cx="10728929" cy="617220"/>
+            <a:off x="6583680" y="1508760"/>
+            <a:ext cx="4876769" cy="1028700"/>
           </a:xfrm>
           <a:prstGeom prst="rect">
             <a:avLst/>
@@ -12055,14 +12630,14 @@
       </p:sp>
       <p:sp>
         <p:nvSpPr>
-          <p:cNvPr id="4" name="TextBox 3"/>
+          <p:cNvPr id="5" name="TextBox 4"/>
           <p:cNvSpPr txBox="1"/>
           <p:nvPr/>
         </p:nvSpPr>
         <p:spPr>
           <a:xfrm>
-            <a:off x="731520" y="2057400"/>
-            <a:ext cx="10728929" cy="754380"/>
+            <a:off x="6583680" y="2811780"/>
+            <a:ext cx="4876769" cy="3223260"/>
           </a:xfrm>
           <a:prstGeom prst="rect">
             <a:avLst/>
@@ -12112,764 +12687,6 @@
           </a:p>
         </p:txBody>
       </p:sp>
-      <p:graphicFrame>
-        <p:nvGraphicFramePr>
-          <p:cNvPr id="5" name="compiled_table"/>
-          <p:cNvGraphicFramePr>
-            <a:graphicFrameLocks noGrp="1"/>
-          </p:cNvGraphicFramePr>
-          <p:nvPr/>
-        </p:nvGraphicFramePr>
-        <p:xfrm>
-          <a:off x="731520" y="3086100"/>
-          <a:ext cx="5120640" cy="1041400"/>
-        </p:xfrm>
-        <a:graphic>
-          <a:graphicData uri="http://schemas.openxmlformats.org/drawingml/2006/table">
-            <a:tbl>
-              <a:tblPr firstRow="1" bandRow="1">
-                <a:tableStyleId>{5C22544A-7EE6-4342-B048-85BDC9FD1C3A}</a:tableStyleId>
-              </a:tblPr>
-              <a:tblGrid>
-                <a:gridCol w="1283906"/>
-                <a:gridCol w="909225"/>
-                <a:gridCol w="909225"/>
-                <a:gridCol w="1109055"/>
-                <a:gridCol w="909229"/>
-              </a:tblGrid>
-              <a:tr h="381000">
-                <a:tc>
-                  <a:txBody>
-                    <a:bodyPr wrap="square"/>
-                    <a:lstStyle/>
-                    <a:p>
-                      <a:pPr algn="ctr"/>
-                      <a:r>
-                        <a:rPr sz="1000" b="1">
-                          <a:solidFill>
-                            <a:srgbClr val="FFFFFF"/>
-                          </a:solidFill>
-                          <a:latin typeface="Microsoft YaHei"/>
-                        </a:rPr>
-                        <a:t>估值指标</a:t>
-                      </a:r>
-                    </a:p>
-                  </a:txBody>
-                  <a:tcPr marL="63500" marR="63500" marT="38100" marB="38100" anchor="ctr">
-                    <a:lnL w="7620">
-                      <a:solidFill>
-                        <a:srgbClr val="D9E2EC"/>
-                      </a:solidFill>
-                      <a:prstDash val="solid"/>
-                    </a:lnL>
-                    <a:lnR w="7620">
-                      <a:solidFill>
-                        <a:srgbClr val="D9E2EC"/>
-                      </a:solidFill>
-                      <a:prstDash val="solid"/>
-                    </a:lnR>
-                    <a:lnT w="7620">
-                      <a:solidFill>
-                        <a:srgbClr val="D9E2EC"/>
-                      </a:solidFill>
-                      <a:prstDash val="solid"/>
-                    </a:lnT>
-                    <a:lnB w="7620">
-                      <a:solidFill>
-                        <a:srgbClr val="D9E2EC"/>
-                      </a:solidFill>
-                      <a:prstDash val="solid"/>
-                    </a:lnB>
-                    <a:solidFill>
-                      <a:srgbClr val="102A43"/>
-                    </a:solidFill>
-                  </a:tcPr>
-                </a:tc>
-                <a:tc>
-                  <a:txBody>
-                    <a:bodyPr wrap="square"/>
-                    <a:lstStyle/>
-                    <a:p>
-                      <a:pPr algn="ctr"/>
-                      <a:r>
-                        <a:rPr sz="1000" b="1">
-                          <a:solidFill>
-                            <a:srgbClr val="FFFFFF"/>
-                          </a:solidFill>
-                          <a:latin typeface="Microsoft YaHei"/>
-                        </a:rPr>
-                        <a:t>泉峰控股</a:t>
-                      </a:r>
-                    </a:p>
-                  </a:txBody>
-                  <a:tcPr marL="63500" marR="63500" marT="38100" marB="38100" anchor="ctr">
-                    <a:lnL w="7620">
-                      <a:solidFill>
-                        <a:srgbClr val="D9E2EC"/>
-                      </a:solidFill>
-                      <a:prstDash val="solid"/>
-                    </a:lnL>
-                    <a:lnR w="7620">
-                      <a:solidFill>
-                        <a:srgbClr val="D9E2EC"/>
-                      </a:solidFill>
-                      <a:prstDash val="solid"/>
-                    </a:lnR>
-                    <a:lnT w="7620">
-                      <a:solidFill>
-                        <a:srgbClr val="D9E2EC"/>
-                      </a:solidFill>
-                      <a:prstDash val="solid"/>
-                    </a:lnT>
-                    <a:lnB w="7620">
-                      <a:solidFill>
-                        <a:srgbClr val="D9E2EC"/>
-                      </a:solidFill>
-                      <a:prstDash val="solid"/>
-                    </a:lnB>
-                    <a:solidFill>
-                      <a:srgbClr val="102A43"/>
-                    </a:solidFill>
-                  </a:tcPr>
-                </a:tc>
-                <a:tc>
-                  <a:txBody>
-                    <a:bodyPr wrap="square"/>
-                    <a:lstStyle/>
-                    <a:p>
-                      <a:pPr algn="ctr"/>
-                      <a:r>
-                        <a:rPr sz="1000" b="1">
-                          <a:solidFill>
-                            <a:srgbClr val="FFFFFF"/>
-                          </a:solidFill>
-                          <a:latin typeface="Microsoft YaHei"/>
-                        </a:rPr>
-                        <a:t>创科实业</a:t>
-                      </a:r>
-                    </a:p>
-                  </a:txBody>
-                  <a:tcPr marL="63500" marR="63500" marT="38100" marB="38100" anchor="ctr">
-                    <a:lnL w="7620">
-                      <a:solidFill>
-                        <a:srgbClr val="D9E2EC"/>
-                      </a:solidFill>
-                      <a:prstDash val="solid"/>
-                    </a:lnL>
-                    <a:lnR w="7620">
-                      <a:solidFill>
-                        <a:srgbClr val="D9E2EC"/>
-                      </a:solidFill>
-                      <a:prstDash val="solid"/>
-                    </a:lnR>
-                    <a:lnT w="7620">
-                      <a:solidFill>
-                        <a:srgbClr val="D9E2EC"/>
-                      </a:solidFill>
-                      <a:prstDash val="solid"/>
-                    </a:lnT>
-                    <a:lnB w="7620">
-                      <a:solidFill>
-                        <a:srgbClr val="D9E2EC"/>
-                      </a:solidFill>
-                      <a:prstDash val="solid"/>
-                    </a:lnB>
-                    <a:solidFill>
-                      <a:srgbClr val="102A43"/>
-                    </a:solidFill>
-                  </a:tcPr>
-                </a:tc>
-                <a:tc>
-                  <a:txBody>
-                    <a:bodyPr wrap="square"/>
-                    <a:lstStyle/>
-                    <a:p>
-                      <a:pPr algn="ctr"/>
-                      <a:r>
-                        <a:rPr sz="1000" b="1">
-                          <a:solidFill>
-                            <a:srgbClr val="FFFFFF"/>
-                          </a:solidFill>
-                          <a:latin typeface="Microsoft YaHei"/>
-                        </a:rPr>
-                        <a:t>可比公司均值</a:t>
-                      </a:r>
-                    </a:p>
-                  </a:txBody>
-                  <a:tcPr marL="63500" marR="63500" marT="38100" marB="38100" anchor="ctr">
-                    <a:lnL w="7620">
-                      <a:solidFill>
-                        <a:srgbClr val="D9E2EC"/>
-                      </a:solidFill>
-                      <a:prstDash val="solid"/>
-                    </a:lnL>
-                    <a:lnR w="7620">
-                      <a:solidFill>
-                        <a:srgbClr val="D9E2EC"/>
-                      </a:solidFill>
-                      <a:prstDash val="solid"/>
-                    </a:lnR>
-                    <a:lnT w="7620">
-                      <a:solidFill>
-                        <a:srgbClr val="D9E2EC"/>
-                      </a:solidFill>
-                      <a:prstDash val="solid"/>
-                    </a:lnT>
-                    <a:lnB w="7620">
-                      <a:solidFill>
-                        <a:srgbClr val="D9E2EC"/>
-                      </a:solidFill>
-                      <a:prstDash val="solid"/>
-                    </a:lnB>
-                    <a:solidFill>
-                      <a:srgbClr val="102A43"/>
-                    </a:solidFill>
-                  </a:tcPr>
-                </a:tc>
-                <a:tc>
-                  <a:txBody>
-                    <a:bodyPr wrap="square"/>
-                    <a:lstStyle/>
-                    <a:p>
-                      <a:pPr algn="ctr"/>
-                      <a:r>
-                        <a:rPr sz="1000" b="1">
-                          <a:solidFill>
-                            <a:srgbClr val="FFFFFF"/>
-                          </a:solidFill>
-                          <a:latin typeface="Microsoft YaHei"/>
-                        </a:rPr>
-                        <a:t>巨星科技</a:t>
-                      </a:r>
-                    </a:p>
-                  </a:txBody>
-                  <a:tcPr marL="63500" marR="63500" marT="38100" marB="38100" anchor="ctr">
-                    <a:lnL w="7620">
-                      <a:solidFill>
-                        <a:srgbClr val="D9E2EC"/>
-                      </a:solidFill>
-                      <a:prstDash val="solid"/>
-                    </a:lnL>
-                    <a:lnR w="7620">
-                      <a:solidFill>
-                        <a:srgbClr val="D9E2EC"/>
-                      </a:solidFill>
-                      <a:prstDash val="solid"/>
-                    </a:lnR>
-                    <a:lnT w="7620">
-                      <a:solidFill>
-                        <a:srgbClr val="D9E2EC"/>
-                      </a:solidFill>
-                      <a:prstDash val="solid"/>
-                    </a:lnT>
-                    <a:lnB w="7620">
-                      <a:solidFill>
-                        <a:srgbClr val="D9E2EC"/>
-                      </a:solidFill>
-                      <a:prstDash val="solid"/>
-                    </a:lnB>
-                    <a:solidFill>
-                      <a:srgbClr val="102A43"/>
-                    </a:solidFill>
-                  </a:tcPr>
-                </a:tc>
-              </a:tr>
-              <a:tr h="330200">
-                <a:tc>
-                  <a:txBody>
-                    <a:bodyPr wrap="square"/>
-                    <a:lstStyle/>
-                    <a:p>
-                      <a:pPr algn="ctr"/>
-                      <a:r>
-                        <a:rPr sz="1000" b="1">
-                          <a:solidFill>
-                            <a:srgbClr val="64748B"/>
-                          </a:solidFill>
-                          <a:latin typeface="Microsoft YaHei"/>
-                        </a:rPr>
-                        <a:t>2025E PE (X)</a:t>
-                      </a:r>
-                    </a:p>
-                  </a:txBody>
-                  <a:tcPr marL="63500" marR="63500" marT="38100" marB="38100" anchor="ctr">
-                    <a:lnL w="7620">
-                      <a:solidFill>
-                        <a:srgbClr val="D9E2EC"/>
-                      </a:solidFill>
-                      <a:prstDash val="solid"/>
-                    </a:lnL>
-                    <a:lnR w="7620">
-                      <a:solidFill>
-                        <a:srgbClr val="D9E2EC"/>
-                      </a:solidFill>
-                      <a:prstDash val="solid"/>
-                    </a:lnR>
-                    <a:lnT w="7620">
-                      <a:solidFill>
-                        <a:srgbClr val="D9E2EC"/>
-                      </a:solidFill>
-                      <a:prstDash val="solid"/>
-                    </a:lnT>
-                    <a:lnB w="7620">
-                      <a:solidFill>
-                        <a:srgbClr val="D9E2EC"/>
-                      </a:solidFill>
-                      <a:prstDash val="solid"/>
-                    </a:lnB>
-                    <a:solidFill>
-                      <a:srgbClr val="FFFFFF"/>
-                    </a:solidFill>
-                  </a:tcPr>
-                </a:tc>
-                <a:tc>
-                  <a:txBody>
-                    <a:bodyPr wrap="square"/>
-                    <a:lstStyle/>
-                    <a:p>
-                      <a:pPr algn="ctr"/>
-                      <a:r>
-                        <a:rPr sz="1000" b="0">
-                          <a:solidFill>
-                            <a:srgbClr val="64748B"/>
-                          </a:solidFill>
-                          <a:latin typeface="Microsoft YaHei"/>
-                        </a:rPr>
-                        <a:t>6.6</a:t>
-                      </a:r>
-                    </a:p>
-                  </a:txBody>
-                  <a:tcPr marL="63500" marR="63500" marT="38100" marB="38100" anchor="ctr">
-                    <a:lnL w="7620">
-                      <a:solidFill>
-                        <a:srgbClr val="D9E2EC"/>
-                      </a:solidFill>
-                      <a:prstDash val="solid"/>
-                    </a:lnL>
-                    <a:lnR w="7620">
-                      <a:solidFill>
-                        <a:srgbClr val="D9E2EC"/>
-                      </a:solidFill>
-                      <a:prstDash val="solid"/>
-                    </a:lnR>
-                    <a:lnT w="7620">
-                      <a:solidFill>
-                        <a:srgbClr val="D9E2EC"/>
-                      </a:solidFill>
-                      <a:prstDash val="solid"/>
-                    </a:lnT>
-                    <a:lnB w="7620">
-                      <a:solidFill>
-                        <a:srgbClr val="D9E2EC"/>
-                      </a:solidFill>
-                      <a:prstDash val="solid"/>
-                    </a:lnB>
-                    <a:solidFill>
-                      <a:srgbClr val="FFFFFF"/>
-                    </a:solidFill>
-                  </a:tcPr>
-                </a:tc>
-                <a:tc>
-                  <a:txBody>
-                    <a:bodyPr wrap="square"/>
-                    <a:lstStyle/>
-                    <a:p>
-                      <a:pPr algn="ctr"/>
-                      <a:r>
-                        <a:rPr sz="1000" b="0">
-                          <a:solidFill>
-                            <a:srgbClr val="64748B"/>
-                          </a:solidFill>
-                          <a:latin typeface="Microsoft YaHei"/>
-                        </a:rPr>
-                        <a:t>15.2</a:t>
-                      </a:r>
-                    </a:p>
-                  </a:txBody>
-                  <a:tcPr marL="63500" marR="63500" marT="38100" marB="38100" anchor="ctr">
-                    <a:lnL w="7620">
-                      <a:solidFill>
-                        <a:srgbClr val="D9E2EC"/>
-                      </a:solidFill>
-                      <a:prstDash val="solid"/>
-                    </a:lnL>
-                    <a:lnR w="7620">
-                      <a:solidFill>
-                        <a:srgbClr val="D9E2EC"/>
-                      </a:solidFill>
-                      <a:prstDash val="solid"/>
-                    </a:lnR>
-                    <a:lnT w="7620">
-                      <a:solidFill>
-                        <a:srgbClr val="D9E2EC"/>
-                      </a:solidFill>
-                      <a:prstDash val="solid"/>
-                    </a:lnT>
-                    <a:lnB w="7620">
-                      <a:solidFill>
-                        <a:srgbClr val="D9E2EC"/>
-                      </a:solidFill>
-                      <a:prstDash val="solid"/>
-                    </a:lnB>
-                    <a:solidFill>
-                      <a:srgbClr val="FFFFFF"/>
-                    </a:solidFill>
-                  </a:tcPr>
-                </a:tc>
-                <a:tc>
-                  <a:txBody>
-                    <a:bodyPr wrap="square"/>
-                    <a:lstStyle/>
-                    <a:p>
-                      <a:pPr algn="ctr"/>
-                      <a:r>
-                        <a:rPr sz="1000" b="0">
-                          <a:solidFill>
-                            <a:srgbClr val="64748B"/>
-                          </a:solidFill>
-                          <a:latin typeface="Microsoft YaHei"/>
-                        </a:rPr>
-                        <a:t>10.9</a:t>
-                      </a:r>
-                    </a:p>
-                  </a:txBody>
-                  <a:tcPr marL="63500" marR="63500" marT="38100" marB="38100" anchor="ctr">
-                    <a:lnL w="7620">
-                      <a:solidFill>
-                        <a:srgbClr val="D9E2EC"/>
-                      </a:solidFill>
-                      <a:prstDash val="solid"/>
-                    </a:lnL>
-                    <a:lnR w="7620">
-                      <a:solidFill>
-                        <a:srgbClr val="D9E2EC"/>
-                      </a:solidFill>
-                      <a:prstDash val="solid"/>
-                    </a:lnR>
-                    <a:lnT w="7620">
-                      <a:solidFill>
-                        <a:srgbClr val="D9E2EC"/>
-                      </a:solidFill>
-                      <a:prstDash val="solid"/>
-                    </a:lnT>
-                    <a:lnB w="7620">
-                      <a:solidFill>
-                        <a:srgbClr val="D9E2EC"/>
-                      </a:solidFill>
-                      <a:prstDash val="solid"/>
-                    </a:lnB>
-                    <a:solidFill>
-                      <a:srgbClr val="FFFFFF"/>
-                    </a:solidFill>
-                  </a:tcPr>
-                </a:tc>
-                <a:tc>
-                  <a:txBody>
-                    <a:bodyPr wrap="square"/>
-                    <a:lstStyle/>
-                    <a:p>
-                      <a:pPr algn="ctr"/>
-                      <a:r>
-                        <a:rPr sz="1000" b="0">
-                          <a:solidFill>
-                            <a:srgbClr val="64748B"/>
-                          </a:solidFill>
-                          <a:latin typeface="Microsoft YaHei"/>
-                        </a:rPr>
-                        <a:t>12</a:t>
-                      </a:r>
-                    </a:p>
-                  </a:txBody>
-                  <a:tcPr marL="63500" marR="63500" marT="38100" marB="38100" anchor="ctr">
-                    <a:lnL w="7620">
-                      <a:solidFill>
-                        <a:srgbClr val="D9E2EC"/>
-                      </a:solidFill>
-                      <a:prstDash val="solid"/>
-                    </a:lnL>
-                    <a:lnR w="7620">
-                      <a:solidFill>
-                        <a:srgbClr val="D9E2EC"/>
-                      </a:solidFill>
-                      <a:prstDash val="solid"/>
-                    </a:lnR>
-                    <a:lnT w="7620">
-                      <a:solidFill>
-                        <a:srgbClr val="D9E2EC"/>
-                      </a:solidFill>
-                      <a:prstDash val="solid"/>
-                    </a:lnT>
-                    <a:lnB w="7620">
-                      <a:solidFill>
-                        <a:srgbClr val="D9E2EC"/>
-                      </a:solidFill>
-                      <a:prstDash val="solid"/>
-                    </a:lnB>
-                    <a:solidFill>
-                      <a:srgbClr val="FFFFFF"/>
-                    </a:solidFill>
-                  </a:tcPr>
-                </a:tc>
-              </a:tr>
-              <a:tr h="330200">
-                <a:tc>
-                  <a:txBody>
-                    <a:bodyPr wrap="square"/>
-                    <a:lstStyle/>
-                    <a:p>
-                      <a:pPr algn="ctr"/>
-                      <a:r>
-                        <a:rPr sz="1000" b="1">
-                          <a:solidFill>
-                            <a:srgbClr val="64748B"/>
-                          </a:solidFill>
-                          <a:latin typeface="Microsoft YaHei"/>
-                        </a:rPr>
-                        <a:t>2026E PE (X)</a:t>
-                      </a:r>
-                    </a:p>
-                  </a:txBody>
-                  <a:tcPr marL="63500" marR="63500" marT="38100" marB="38100" anchor="ctr">
-                    <a:lnL w="7620">
-                      <a:solidFill>
-                        <a:srgbClr val="D9E2EC"/>
-                      </a:solidFill>
-                      <a:prstDash val="solid"/>
-                    </a:lnL>
-                    <a:lnR w="7620">
-                      <a:solidFill>
-                        <a:srgbClr val="D9E2EC"/>
-                      </a:solidFill>
-                      <a:prstDash val="solid"/>
-                    </a:lnR>
-                    <a:lnT w="7620">
-                      <a:solidFill>
-                        <a:srgbClr val="D9E2EC"/>
-                      </a:solidFill>
-                      <a:prstDash val="solid"/>
-                    </a:lnT>
-                    <a:lnB w="7620">
-                      <a:solidFill>
-                        <a:srgbClr val="D9E2EC"/>
-                      </a:solidFill>
-                      <a:prstDash val="solid"/>
-                    </a:lnB>
-                    <a:solidFill>
-                      <a:srgbClr val="F5F7FA"/>
-                    </a:solidFill>
-                  </a:tcPr>
-                </a:tc>
-                <a:tc>
-                  <a:txBody>
-                    <a:bodyPr wrap="square"/>
-                    <a:lstStyle/>
-                    <a:p>
-                      <a:pPr algn="ctr"/>
-                      <a:r>
-                        <a:rPr sz="1000" b="0">
-                          <a:solidFill>
-                            <a:srgbClr val="64748B"/>
-                          </a:solidFill>
-                          <a:latin typeface="Microsoft YaHei"/>
-                        </a:rPr>
-                        <a:t>5.3</a:t>
-                      </a:r>
-                    </a:p>
-                  </a:txBody>
-                  <a:tcPr marL="63500" marR="63500" marT="38100" marB="38100" anchor="ctr">
-                    <a:lnL w="7620">
-                      <a:solidFill>
-                        <a:srgbClr val="D9E2EC"/>
-                      </a:solidFill>
-                      <a:prstDash val="solid"/>
-                    </a:lnL>
-                    <a:lnR w="7620">
-                      <a:solidFill>
-                        <a:srgbClr val="D9E2EC"/>
-                      </a:solidFill>
-                      <a:prstDash val="solid"/>
-                    </a:lnR>
-                    <a:lnT w="7620">
-                      <a:solidFill>
-                        <a:srgbClr val="D9E2EC"/>
-                      </a:solidFill>
-                      <a:prstDash val="solid"/>
-                    </a:lnT>
-                    <a:lnB w="7620">
-                      <a:solidFill>
-                        <a:srgbClr val="D9E2EC"/>
-                      </a:solidFill>
-                      <a:prstDash val="solid"/>
-                    </a:lnB>
-                    <a:solidFill>
-                      <a:srgbClr val="F5F7FA"/>
-                    </a:solidFill>
-                  </a:tcPr>
-                </a:tc>
-                <a:tc>
-                  <a:txBody>
-                    <a:bodyPr wrap="square"/>
-                    <a:lstStyle/>
-                    <a:p>
-                      <a:pPr algn="ctr"/>
-                      <a:r>
-                        <a:rPr sz="1000" b="0">
-                          <a:solidFill>
-                            <a:srgbClr val="64748B"/>
-                          </a:solidFill>
-                          <a:latin typeface="Microsoft YaHei"/>
-                        </a:rPr>
-                        <a:t>13.2</a:t>
-                      </a:r>
-                    </a:p>
-                  </a:txBody>
-                  <a:tcPr marL="63500" marR="63500" marT="38100" marB="38100" anchor="ctr">
-                    <a:lnL w="7620">
-                      <a:solidFill>
-                        <a:srgbClr val="D9E2EC"/>
-                      </a:solidFill>
-                      <a:prstDash val="solid"/>
-                    </a:lnL>
-                    <a:lnR w="7620">
-                      <a:solidFill>
-                        <a:srgbClr val="D9E2EC"/>
-                      </a:solidFill>
-                      <a:prstDash val="solid"/>
-                    </a:lnR>
-                    <a:lnT w="7620">
-                      <a:solidFill>
-                        <a:srgbClr val="D9E2EC"/>
-                      </a:solidFill>
-                      <a:prstDash val="solid"/>
-                    </a:lnT>
-                    <a:lnB w="7620">
-                      <a:solidFill>
-                        <a:srgbClr val="D9E2EC"/>
-                      </a:solidFill>
-                      <a:prstDash val="solid"/>
-                    </a:lnB>
-                    <a:solidFill>
-                      <a:srgbClr val="F5F7FA"/>
-                    </a:solidFill>
-                  </a:tcPr>
-                </a:tc>
-                <a:tc>
-                  <a:txBody>
-                    <a:bodyPr wrap="square"/>
-                    <a:lstStyle/>
-                    <a:p>
-                      <a:pPr algn="ctr"/>
-                      <a:r>
-                        <a:rPr sz="1000" b="0">
-                          <a:solidFill>
-                            <a:srgbClr val="64748B"/>
-                          </a:solidFill>
-                          <a:latin typeface="Microsoft YaHei"/>
-                        </a:rPr>
-                        <a:t>9.2</a:t>
-                      </a:r>
-                    </a:p>
-                  </a:txBody>
-                  <a:tcPr marL="63500" marR="63500" marT="38100" marB="38100" anchor="ctr">
-                    <a:lnL w="7620">
-                      <a:solidFill>
-                        <a:srgbClr val="D9E2EC"/>
-                      </a:solidFill>
-                      <a:prstDash val="solid"/>
-                    </a:lnL>
-                    <a:lnR w="7620">
-                      <a:solidFill>
-                        <a:srgbClr val="D9E2EC"/>
-                      </a:solidFill>
-                      <a:prstDash val="solid"/>
-                    </a:lnR>
-                    <a:lnT w="7620">
-                      <a:solidFill>
-                        <a:srgbClr val="D9E2EC"/>
-                      </a:solidFill>
-                      <a:prstDash val="solid"/>
-                    </a:lnT>
-                    <a:lnB w="7620">
-                      <a:solidFill>
-                        <a:srgbClr val="D9E2EC"/>
-                      </a:solidFill>
-                      <a:prstDash val="solid"/>
-                    </a:lnB>
-                    <a:solidFill>
-                      <a:srgbClr val="F5F7FA"/>
-                    </a:solidFill>
-                  </a:tcPr>
-                </a:tc>
-                <a:tc>
-                  <a:txBody>
-                    <a:bodyPr wrap="square"/>
-                    <a:lstStyle/>
-                    <a:p>
-                      <a:pPr algn="ctr"/>
-                      <a:r>
-                        <a:rPr sz="1000" b="0">
-                          <a:solidFill>
-                            <a:srgbClr val="64748B"/>
-                          </a:solidFill>
-                          <a:latin typeface="Microsoft YaHei"/>
-                        </a:rPr>
-                        <a:t>9.7</a:t>
-                      </a:r>
-                    </a:p>
-                  </a:txBody>
-                  <a:tcPr marL="63500" marR="63500" marT="38100" marB="38100" anchor="ctr">
-                    <a:lnL w="7620">
-                      <a:solidFill>
-                        <a:srgbClr val="D9E2EC"/>
-                      </a:solidFill>
-                      <a:prstDash val="solid"/>
-                    </a:lnL>
-                    <a:lnR w="7620">
-                      <a:solidFill>
-                        <a:srgbClr val="D9E2EC"/>
-                      </a:solidFill>
-                      <a:prstDash val="solid"/>
-                    </a:lnR>
-                    <a:lnT w="7620">
-                      <a:solidFill>
-                        <a:srgbClr val="D9E2EC"/>
-                      </a:solidFill>
-                      <a:prstDash val="solid"/>
-                    </a:lnT>
-                    <a:lnB w="7620">
-                      <a:solidFill>
-                        <a:srgbClr val="D9E2EC"/>
-                      </a:solidFill>
-                      <a:prstDash val="solid"/>
-                    </a:lnB>
-                    <a:solidFill>
-                      <a:srgbClr val="F5F7FA"/>
-                    </a:solidFill>
-                  </a:tcPr>
-                </a:tc>
-              </a:tr>
-            </a:tbl>
-          </a:graphicData>
-        </a:graphic>
-      </p:graphicFrame>
-      <p:graphicFrame>
-        <p:nvGraphicFramePr>
-          <p:cNvPr id="6" name="Chart 5"/>
-          <p:cNvGraphicFramePr>
-            <a:graphicFrameLocks noGrp="1"/>
-          </p:cNvGraphicFramePr>
-          <p:nvPr/>
-        </p:nvGraphicFramePr>
-        <p:xfrm>
-          <a:off x="6339809" y="3086100"/>
-          <a:ext cx="5120640" cy="2948940"/>
-        </p:xfrm>
-        <a:graphic>
-          <a:graphicData uri="http://schemas.openxmlformats.org/drawingml/2006/chart">
-            <c:chart xmlns:c="http://schemas.openxmlformats.org/drawingml/2006/chart" r:id="rId2"/>
-          </a:graphicData>
-        </a:graphic>
-      </p:graphicFrame>
     </p:spTree>
   </p:cSld>
   <p:clrMapOvr>

</xml_diff>